<commit_message>
studies(flume-wall): fix swapped orientation labels (0 deg corner-on, 45 deg flat-on)
At PLAT_ROT_DEG = 45 the 4x4 grid is axis-aligned: its sides are parallel to
the flume walls and a flat row of four buoys faces the waves (span 2.06 m,
0.80 m clearance). At 0 deg it is the diamond (span 2.79 m, 0.44 m clearance).
The docs, the orientation figure and both decks called 45 deg "corner-on" and
0 deg "flat-on"; the labels are swapped, the numbers were right. Wording only:
README, REBUTTAL-sidewall.md, compare_orientations.py (+ figure), both deck
generators and the regenerated decks.

Co-Authored-By: Claude Opus 5.5 <noreply@anthropic.com>
</commit_message>
<xml_diff>
--- a/studies/platform-12buoy/flume-wall-effect/Flume_wall_effect_technical.pptx
+++ b/studies/platform-12buoy/flume-wall-effect/Flume_wall_effect_technical.pptx
@@ -3321,7 +3321,7 @@
                 </a:solidFill>
                 <a:latin typeface="Segoe UI"/>
               </a:rPr>
-              <a:t>The dominant flume artifact is the finite 2.7 m depth, not the walls. 16-buoy platform (4 clusters × 4), 2.5 m to buoy centres, tested corner-on (45°) with ~0.80 m side clearance.</a:t>
+              <a:t>The dominant flume artifact is the finite 2.7 m depth, not the walls. 16-buoy platform (4 clusters × 4), 2.5 m to buoy centres, tested flat-on (45°) with ~0.80 m side clearance.</a:t>
             </a:r>
           </a:p>
         </p:txBody>
@@ -3857,7 +3857,7 @@
                 </a:solidFill>
                 <a:latin typeface="Segoe UI"/>
               </a:rPr>
-              <a:t>The platform is tested corner-on (45°, 0.80 m/side). Turning it flat-on — 0°, the widest orientation at 0.44 m/side (a 90° turn is a symmetry no-op) — </a:t>
+              <a:t>The platform is tested flat-on (45°, 0.80 m/side). Turning it corner-on — 0°, the widest orientation at 0.44 m/side (a 90° turn is a symmetry no-op) — </a:t>
             </a:r>
             <a:r>
               <a:rPr sz="1250" b="1" i="0">
@@ -5219,7 +5219,7 @@
                 </a:solidFill>
                 <a:latin typeface="Segoe UI"/>
               </a:rPr>
-              <a:t>2.5 m to buoy centres, corner-on (45°); span across the flume 2.06 m </a:t>
+              <a:t>2.5 m to buoy centres, flat-on (45°); span across the flume 2.06 m </a:t>
             </a:r>
             <a:r>
               <a:rPr sz="1700" b="1" i="0">
@@ -5376,7 +5376,7 @@
                 </a:solidFill>
                 <a:latin typeface="Segoe UI"/>
               </a:rPr>
-              <a:t>Reviewer's 0.6 m: at the 45° test orientation the as-built clearance is ~0.80 m; the widest (flat-on) orientation, 0.44 m, gives the same result — see the orientation slide.</a:t>
+              <a:t>Reviewer's 0.6 m: at the 45° test orientation the as-built clearance is ~0.80 m; the widest (corner-on) orientation, 0.44 m, gives the same result — see the orientation slide.</a:t>
             </a:r>
           </a:p>
         </p:txBody>

</xml_diff>